<commit_message>
Making classes to made code moduler
</commit_message>
<xml_diff>
--- a/Hive to Iceberg.pptx
+++ b/Hive to Iceberg.pptx
@@ -117,6 +117,11 @@
       </a:defRPr>
     </a:lvl9pPr>
   </p:defaultTextStyle>
+  <p:extLst>
+    <p:ext uri="{EFAFB233-063F-42B5-8137-9DF3F51BA10A}">
+      <p15:sldGuideLst xmlns:p15="http://schemas.microsoft.com/office/powerpoint/2012/main"/>
+    </p:ext>
+  </p:extLst>
 </p:presentation>
 </file>
 
@@ -267,7 +272,7 @@
           <a:p>
             <a:fld id="{EEF15244-4AC2-5742-BBD3-2092CB8772BC}" type="datetimeFigureOut">
               <a:rPr lang="en-US" smtClean="0"/>
-              <a:t>9/15/25</a:t>
+              <a:t>9/16/25</a:t>
             </a:fld>
             <a:endParaRPr lang="en-US"/>
           </a:p>
@@ -465,7 +470,7 @@
           <a:p>
             <a:fld id="{EEF15244-4AC2-5742-BBD3-2092CB8772BC}" type="datetimeFigureOut">
               <a:rPr lang="en-US" smtClean="0"/>
-              <a:t>9/15/25</a:t>
+              <a:t>9/16/25</a:t>
             </a:fld>
             <a:endParaRPr lang="en-US"/>
           </a:p>
@@ -673,7 +678,7 @@
           <a:p>
             <a:fld id="{EEF15244-4AC2-5742-BBD3-2092CB8772BC}" type="datetimeFigureOut">
               <a:rPr lang="en-US" smtClean="0"/>
-              <a:t>9/15/25</a:t>
+              <a:t>9/16/25</a:t>
             </a:fld>
             <a:endParaRPr lang="en-US"/>
           </a:p>
@@ -871,7 +876,7 @@
           <a:p>
             <a:fld id="{EEF15244-4AC2-5742-BBD3-2092CB8772BC}" type="datetimeFigureOut">
               <a:rPr lang="en-US" smtClean="0"/>
-              <a:t>9/15/25</a:t>
+              <a:t>9/16/25</a:t>
             </a:fld>
             <a:endParaRPr lang="en-US"/>
           </a:p>
@@ -1146,7 +1151,7 @@
           <a:p>
             <a:fld id="{EEF15244-4AC2-5742-BBD3-2092CB8772BC}" type="datetimeFigureOut">
               <a:rPr lang="en-US" smtClean="0"/>
-              <a:t>9/15/25</a:t>
+              <a:t>9/16/25</a:t>
             </a:fld>
             <a:endParaRPr lang="en-US"/>
           </a:p>
@@ -1411,7 +1416,7 @@
           <a:p>
             <a:fld id="{EEF15244-4AC2-5742-BBD3-2092CB8772BC}" type="datetimeFigureOut">
               <a:rPr lang="en-US" smtClean="0"/>
-              <a:t>9/15/25</a:t>
+              <a:t>9/16/25</a:t>
             </a:fld>
             <a:endParaRPr lang="en-US"/>
           </a:p>
@@ -1823,7 +1828,7 @@
           <a:p>
             <a:fld id="{EEF15244-4AC2-5742-BBD3-2092CB8772BC}" type="datetimeFigureOut">
               <a:rPr lang="en-US" smtClean="0"/>
-              <a:t>9/15/25</a:t>
+              <a:t>9/16/25</a:t>
             </a:fld>
             <a:endParaRPr lang="en-US"/>
           </a:p>
@@ -1964,7 +1969,7 @@
           <a:p>
             <a:fld id="{EEF15244-4AC2-5742-BBD3-2092CB8772BC}" type="datetimeFigureOut">
               <a:rPr lang="en-US" smtClean="0"/>
-              <a:t>9/15/25</a:t>
+              <a:t>9/16/25</a:t>
             </a:fld>
             <a:endParaRPr lang="en-US"/>
           </a:p>
@@ -2077,7 +2082,7 @@
           <a:p>
             <a:fld id="{EEF15244-4AC2-5742-BBD3-2092CB8772BC}" type="datetimeFigureOut">
               <a:rPr lang="en-US" smtClean="0"/>
-              <a:t>9/15/25</a:t>
+              <a:t>9/16/25</a:t>
             </a:fld>
             <a:endParaRPr lang="en-US"/>
           </a:p>
@@ -2388,7 +2393,7 @@
           <a:p>
             <a:fld id="{EEF15244-4AC2-5742-BBD3-2092CB8772BC}" type="datetimeFigureOut">
               <a:rPr lang="en-US" smtClean="0"/>
-              <a:t>9/15/25</a:t>
+              <a:t>9/16/25</a:t>
             </a:fld>
             <a:endParaRPr lang="en-US"/>
           </a:p>
@@ -2676,7 +2681,7 @@
           <a:p>
             <a:fld id="{EEF15244-4AC2-5742-BBD3-2092CB8772BC}" type="datetimeFigureOut">
               <a:rPr lang="en-US" smtClean="0"/>
-              <a:t>9/15/25</a:t>
+              <a:t>9/16/25</a:t>
             </a:fld>
             <a:endParaRPr lang="en-US"/>
           </a:p>
@@ -2917,7 +2922,7 @@
           <a:p>
             <a:fld id="{EEF15244-4AC2-5742-BBD3-2092CB8772BC}" type="datetimeFigureOut">
               <a:rPr lang="en-US" smtClean="0"/>
-              <a:t>9/15/25</a:t>
+              <a:t>9/16/25</a:t>
             </a:fld>
             <a:endParaRPr lang="en-US"/>
           </a:p>
@@ -8603,7 +8608,7 @@
           <a:p>
             <a:r>
               <a:rPr lang="en-US" dirty="0"/>
-              <a:t>Hive supports storage on AWS S3, ADLS, and GCS through the Hadoop Distributed File System (HDFS). With Hive, non-programmers familiar with SQL can read, write, and manage petabytes of big data.</a:t>
+              <a:t>Hive supports storage on AWS S3, ADLS, and GCS through the Hadoop Distributed File System (HDFS). With Hive, using SQL, can read, write, and manage petabytes of big data.</a:t>
             </a:r>
           </a:p>
           <a:p>

</xml_diff>